<commit_message>
feat: portable Office charts and text metrics, bridge contract updates, session lifecycle
Carries the remaining in-progress worktree state: portable chart rendering and text metrics for the Office engine with their packaging/xlsx contract updates, browser and computer bridge action-schema and tool-def revisions, desktop settings store and IPC validation, transcript tool formatting, and session lifecycle handling. Verified with test:office 99/99, test:quick 98/91/81, computer-host 14/14 and the desktop typecheck.
</commit_message>
<xml_diff>
--- a/src/runtime/office/templates/mixdog-executive.pptx
+++ b/src/runtime/office/templates/mixdog-executive.pptx
@@ -26,6 +26,7 @@
     <p:sldId id="271" r:id="rId17"/>
     <p:sldId id="272" r:id="rId18"/>
     <p:sldId id="273" r:id="rId19"/>
+    <p:sldId id="274" r:id="rId25"/>
   </p:sldIdLst>
   <p:sldSz cx="12192000" cy="6858000"/>
   <p:notesSz cx="6858000" cy="9144000"/>
@@ -17029,6 +17030,593 @@
 </p:sld>
 </file>
 
+<file path=ppt/slides/slide19.xml><?xml version="1.0" encoding="utf-8"?>
+<p:sld xmlns:a="http://schemas.openxmlformats.org/drawingml/2006/main" xmlns:r="http://schemas.openxmlformats.org/officeDocument/2006/relationships" xmlns:p="http://schemas.openxmlformats.org/presentationml/2006/main">
+  <p:cSld>
+    <p:bg>
+      <p:bgPr>
+        <a:solidFill>
+          <a:srgbClr val="FFFFFF"/>
+        </a:solidFill>
+        <a:effectLst/>
+      </p:bgPr>
+    </p:bg>
+    <p:spTree>
+      <p:nvGrpSpPr>
+        <p:cNvPr id="1" name=""/>
+        <p:cNvGrpSpPr/>
+        <p:nvPr/>
+      </p:nvGrpSpPr>
+      <p:grpSpPr>
+        <a:xfrm>
+          <a:off x="0" y="0"/>
+          <a:ext cx="0" cy="0"/>
+          <a:chOff x="0" y="0"/>
+          <a:chExt cx="0" cy="0"/>
+        </a:xfrm>
+      </p:grpSpPr>
+      <p:sp>
+        <p:nvSpPr>
+          <p:cNvPr id="2" name="Mixdog TextBox 2"/>
+          <p:cNvSpPr txBox="1"/>
+          <p:nvPr/>
+        </p:nvSpPr>
+        <p:spPr>
+          <a:xfrm>
+            <a:off x="736600" y="660400"/>
+            <a:ext cx="10693400" cy="736600"/>
+          </a:xfrm>
+          <a:prstGeom prst="rect">
+            <a:avLst/>
+          </a:prstGeom>
+          <a:noFill/>
+          <a:ln>
+            <a:noFill/>
+          </a:ln>
+        </p:spPr>
+        <p:txBody>
+          <a:bodyPr wrap="square" lIns="0" tIns="0" rIns="0" bIns="0">
+            <a:noAutofit/>
+          </a:bodyPr>
+          <a:lstStyle/>
+          <a:p>
+            <a:pPr marL="0" indent="0">
+              <a:buNone/>
+            </a:pPr>
+            <a:r>
+              <a:rPr lang="en-US" sz="3000" b="1" dirty="0">
+                <a:solidFill>
+                  <a:srgbClr val="171A1F"/>
+                </a:solidFill>
+                <a:latin typeface="Georgia"/>
+                <a:ea typeface="Georgia"/>
+                <a:cs typeface="Georgia"/>
+              </a:rPr>
+              <a:t>Comparison at a glance</a:t>
+            </a:r>
+          </a:p>
+        </p:txBody>
+      </p:sp>
+      <p:sp>
+        <p:nvSpPr>
+          <p:cNvPr id="3" name="Mixdog TextBox 3"/>
+          <p:cNvSpPr txBox="1"/>
+          <p:nvPr/>
+        </p:nvSpPr>
+        <p:spPr>
+          <a:xfrm>
+            <a:off x="736600" y="1473200"/>
+            <a:ext cx="10693400" cy="355600"/>
+          </a:xfrm>
+          <a:prstGeom prst="rect">
+            <a:avLst/>
+          </a:prstGeom>
+          <a:noFill/>
+          <a:ln>
+            <a:noFill/>
+          </a:ln>
+        </p:spPr>
+        <p:txBody>
+          <a:bodyPr wrap="square" lIns="0" tIns="0" rIns="0" bIns="0">
+            <a:noAutofit/>
+          </a:bodyPr>
+          <a:lstStyle/>
+          <a:p>
+            <a:pPr marL="0" indent="0">
+              <a:buNone/>
+            </a:pPr>
+            <a:r>
+              <a:rPr lang="en-US" sz="1300" dirty="0">
+                <a:solidFill>
+                  <a:srgbClr val="7C838B"/>
+                </a:solidFill>
+                <a:latin typeface="Arial"/>
+                <a:ea typeface="Arial"/>
+                <a:cs typeface="Arial"/>
+              </a:rPr>
+              <a:t>Baseline versus target across the tracked dimensions</a:t>
+            </a:r>
+          </a:p>
+        </p:txBody>
+      </p:sp>
+      <p:graphicFrame>
+        <p:nvGraphicFramePr>
+          <p:cNvPr id="4" name="Table 4"/>
+          <p:cNvGraphicFramePr>
+            <a:graphicFrameLocks noGrp="1"/>
+          </p:cNvGraphicFramePr>
+          <p:nvPr/>
+        </p:nvGraphicFramePr>
+        <p:xfrm>
+          <a:off x="736600" y="2133600"/>
+          <a:ext cx="10693400" cy="3708400"/>
+        </p:xfrm>
+        <a:graphic>
+          <a:graphicData uri="http://schemas.openxmlformats.org/drawingml/2006/table">
+            <a:tbl>
+              <a:tblPr firstRow="1" bandRow="1"/>
+              <a:tblGrid>
+                <a:gridCol w="3564467"/>
+                <a:gridCol w="3564467"/>
+                <a:gridCol w="3564467"/>
+              </a:tblGrid>
+              <a:tr h="584200">
+                <a:tc>
+                  <a:txBody>
+                    <a:bodyPr wrap="square" lIns="88900" tIns="38100" rIns="88900" bIns="38100" anchor="ctr">
+                      <a:noAutofit/>
+                    </a:bodyPr>
+                    <a:lstStyle/>
+                    <a:p>
+                      <a:pPr marL="0" indent="0" algn="l">
+                        <a:buNone/>
+                      </a:pPr>
+                      <a:r>
+                        <a:rPr lang="en-US" sz="1300" b="1" dirty="0">
+                          <a:solidFill>
+                            <a:srgbClr val="FFFFFF"/>
+                          </a:solidFill>
+                          <a:latin typeface="Arial"/>
+                          <a:ea typeface="Arial"/>
+                          <a:cs typeface="Arial"/>
+                        </a:rPr>
+                        <a:t>Dimension</a:t>
+                      </a:r>
+                    </a:p>
+                  </a:txBody>
+                  <a:tcPr anchor="ctr">
+                    <a:solidFill>
+                      <a:srgbClr val="171A1F"/>
+                    </a:solidFill>
+                  </a:tcPr>
+                </a:tc>
+                <a:tc>
+                  <a:txBody>
+                    <a:bodyPr wrap="square" lIns="88900" tIns="38100" rIns="88900" bIns="38100" anchor="ctr">
+                      <a:noAutofit/>
+                    </a:bodyPr>
+                    <a:lstStyle/>
+                    <a:p>
+                      <a:pPr marL="0" indent="0" algn="l">
+                        <a:buNone/>
+                      </a:pPr>
+                      <a:r>
+                        <a:rPr lang="en-US" sz="1300" b="1" dirty="0">
+                          <a:solidFill>
+                            <a:srgbClr val="FFFFFF"/>
+                          </a:solidFill>
+                          <a:latin typeface="Arial"/>
+                          <a:ea typeface="Arial"/>
+                          <a:cs typeface="Arial"/>
+                        </a:rPr>
+                        <a:t>Baseline</a:t>
+                      </a:r>
+                    </a:p>
+                  </a:txBody>
+                  <a:tcPr anchor="ctr">
+                    <a:solidFill>
+                      <a:srgbClr val="171A1F"/>
+                    </a:solidFill>
+                  </a:tcPr>
+                </a:tc>
+                <a:tc>
+                  <a:txBody>
+                    <a:bodyPr wrap="square" lIns="88900" tIns="38100" rIns="88900" bIns="38100" anchor="ctr">
+                      <a:noAutofit/>
+                    </a:bodyPr>
+                    <a:lstStyle/>
+                    <a:p>
+                      <a:pPr marL="0" indent="0" algn="l">
+                        <a:buNone/>
+                      </a:pPr>
+                      <a:r>
+                        <a:rPr lang="en-US" sz="1300" b="1" dirty="0">
+                          <a:solidFill>
+                            <a:srgbClr val="FFFFFF"/>
+                          </a:solidFill>
+                          <a:latin typeface="Arial"/>
+                          <a:ea typeface="Arial"/>
+                          <a:cs typeface="Arial"/>
+                        </a:rPr>
+                        <a:t>Target</a:t>
+                      </a:r>
+                    </a:p>
+                  </a:txBody>
+                  <a:tcPr anchor="ctr">
+                    <a:solidFill>
+                      <a:srgbClr val="171A1F"/>
+                    </a:solidFill>
+                  </a:tcPr>
+                </a:tc>
+              </a:tr>
+              <a:tr h="774700">
+                <a:tc>
+                  <a:txBody>
+                    <a:bodyPr wrap="square" lIns="88900" tIns="38100" rIns="88900" bIns="38100" anchor="ctr">
+                      <a:noAutofit/>
+                    </a:bodyPr>
+                    <a:lstStyle/>
+                    <a:p>
+                      <a:pPr marL="0" indent="0">
+                        <a:buNone/>
+                      </a:pPr>
+                      <a:r>
+                        <a:rPr lang="en-US" sz="1300" dirty="0">
+                          <a:solidFill>
+                            <a:srgbClr val="3D444C"/>
+                          </a:solidFill>
+                          <a:latin typeface="Arial"/>
+                          <a:ea typeface="Arial"/>
+                          <a:cs typeface="Arial"/>
+                        </a:rPr>
+                        <a:t>Coverage</a:t>
+                      </a:r>
+                    </a:p>
+                  </a:txBody>
+                  <a:tcPr anchor="ctr">
+                    <a:solidFill>
+                      <a:srgbClr val="FFFFFF"/>
+                    </a:solidFill>
+                  </a:tcPr>
+                </a:tc>
+                <a:tc>
+                  <a:txBody>
+                    <a:bodyPr wrap="square" lIns="88900" tIns="38100" rIns="88900" bIns="38100" anchor="ctr">
+                      <a:noAutofit/>
+                    </a:bodyPr>
+                    <a:lstStyle/>
+                    <a:p>
+                      <a:pPr marL="0" indent="0">
+                        <a:buNone/>
+                      </a:pPr>
+                      <a:r>
+                        <a:rPr lang="en-US" sz="1300" dirty="0">
+                          <a:solidFill>
+                            <a:srgbClr val="3D444C"/>
+                          </a:solidFill>
+                          <a:latin typeface="Arial"/>
+                          <a:ea typeface="Arial"/>
+                          <a:cs typeface="Arial"/>
+                        </a:rPr>
+                        <a:t>62%</a:t>
+                      </a:r>
+                    </a:p>
+                  </a:txBody>
+                  <a:tcPr anchor="ctr">
+                    <a:solidFill>
+                      <a:srgbClr val="FFFFFF"/>
+                    </a:solidFill>
+                  </a:tcPr>
+                </a:tc>
+                <a:tc>
+                  <a:txBody>
+                    <a:bodyPr wrap="square" lIns="88900" tIns="38100" rIns="88900" bIns="38100" anchor="ctr">
+                      <a:noAutofit/>
+                    </a:bodyPr>
+                    <a:lstStyle/>
+                    <a:p>
+                      <a:pPr marL="0" indent="0">
+                        <a:buNone/>
+                      </a:pPr>
+                      <a:r>
+                        <a:rPr lang="en-US" sz="1300" dirty="0">
+                          <a:solidFill>
+                            <a:srgbClr val="3D444C"/>
+                          </a:solidFill>
+                          <a:latin typeface="Arial"/>
+                          <a:ea typeface="Arial"/>
+                          <a:cs typeface="Arial"/>
+                        </a:rPr>
+                        <a:t>90%</a:t>
+                      </a:r>
+                    </a:p>
+                  </a:txBody>
+                  <a:tcPr anchor="ctr">
+                    <a:solidFill>
+                      <a:srgbClr val="FFFFFF"/>
+                    </a:solidFill>
+                  </a:tcPr>
+                </a:tc>
+              </a:tr>
+              <a:tr h="774700">
+                <a:tc>
+                  <a:txBody>
+                    <a:bodyPr wrap="square" lIns="88900" tIns="38100" rIns="88900" bIns="38100" anchor="ctr">
+                      <a:noAutofit/>
+                    </a:bodyPr>
+                    <a:lstStyle/>
+                    <a:p>
+                      <a:pPr marL="0" indent="0">
+                        <a:buNone/>
+                      </a:pPr>
+                      <a:r>
+                        <a:rPr lang="en-US" sz="1300" dirty="0">
+                          <a:solidFill>
+                            <a:srgbClr val="3D444C"/>
+                          </a:solidFill>
+                          <a:latin typeface="Arial"/>
+                          <a:ea typeface="Arial"/>
+                          <a:cs typeface="Arial"/>
+                        </a:rPr>
+                        <a:t>Latency</a:t>
+                      </a:r>
+                    </a:p>
+                  </a:txBody>
+                  <a:tcPr anchor="ctr">
+                    <a:solidFill>
+                      <a:srgbClr val="FFFFFF"/>
+                    </a:solidFill>
+                  </a:tcPr>
+                </a:tc>
+                <a:tc>
+                  <a:txBody>
+                    <a:bodyPr wrap="square" lIns="88900" tIns="38100" rIns="88900" bIns="38100" anchor="ctr">
+                      <a:noAutofit/>
+                    </a:bodyPr>
+                    <a:lstStyle/>
+                    <a:p>
+                      <a:pPr marL="0" indent="0">
+                        <a:buNone/>
+                      </a:pPr>
+                      <a:r>
+                        <a:rPr lang="en-US" sz="1300" dirty="0">
+                          <a:solidFill>
+                            <a:srgbClr val="3D444C"/>
+                          </a:solidFill>
+                          <a:latin typeface="Arial"/>
+                          <a:ea typeface="Arial"/>
+                          <a:cs typeface="Arial"/>
+                        </a:rPr>
+                        <a:t>820ms</a:t>
+                      </a:r>
+                    </a:p>
+                  </a:txBody>
+                  <a:tcPr anchor="ctr">
+                    <a:solidFill>
+                      <a:srgbClr val="FFFFFF"/>
+                    </a:solidFill>
+                  </a:tcPr>
+                </a:tc>
+                <a:tc>
+                  <a:txBody>
+                    <a:bodyPr wrap="square" lIns="88900" tIns="38100" rIns="88900" bIns="38100" anchor="ctr">
+                      <a:noAutofit/>
+                    </a:bodyPr>
+                    <a:lstStyle/>
+                    <a:p>
+                      <a:pPr marL="0" indent="0">
+                        <a:buNone/>
+                      </a:pPr>
+                      <a:r>
+                        <a:rPr lang="en-US" sz="1300" dirty="0">
+                          <a:solidFill>
+                            <a:srgbClr val="3D444C"/>
+                          </a:solidFill>
+                          <a:latin typeface="Arial"/>
+                          <a:ea typeface="Arial"/>
+                          <a:cs typeface="Arial"/>
+                        </a:rPr>
+                        <a:t>400ms</a:t>
+                      </a:r>
+                    </a:p>
+                  </a:txBody>
+                  <a:tcPr anchor="ctr">
+                    <a:solidFill>
+                      <a:srgbClr val="FFFFFF"/>
+                    </a:solidFill>
+                  </a:tcPr>
+                </a:tc>
+              </a:tr>
+              <a:tr h="774700">
+                <a:tc>
+                  <a:txBody>
+                    <a:bodyPr wrap="square" lIns="88900" tIns="38100" rIns="88900" bIns="38100" anchor="ctr">
+                      <a:noAutofit/>
+                    </a:bodyPr>
+                    <a:lstStyle/>
+                    <a:p>
+                      <a:pPr marL="0" indent="0">
+                        <a:buNone/>
+                      </a:pPr>
+                      <a:r>
+                        <a:rPr lang="en-US" sz="1300" dirty="0">
+                          <a:solidFill>
+                            <a:srgbClr val="3D444C"/>
+                          </a:solidFill>
+                          <a:latin typeface="Arial"/>
+                          <a:ea typeface="Arial"/>
+                          <a:cs typeface="Arial"/>
+                        </a:rPr>
+                        <a:t>Cost per run</a:t>
+                      </a:r>
+                    </a:p>
+                  </a:txBody>
+                  <a:tcPr anchor="ctr">
+                    <a:solidFill>
+                      <a:srgbClr val="FFFFFF"/>
+                    </a:solidFill>
+                  </a:tcPr>
+                </a:tc>
+                <a:tc>
+                  <a:txBody>
+                    <a:bodyPr wrap="square" lIns="88900" tIns="38100" rIns="88900" bIns="38100" anchor="ctr">
+                      <a:noAutofit/>
+                    </a:bodyPr>
+                    <a:lstStyle/>
+                    <a:p>
+                      <a:pPr marL="0" indent="0">
+                        <a:buNone/>
+                      </a:pPr>
+                      <a:r>
+                        <a:rPr lang="en-US" sz="1300" dirty="0">
+                          <a:solidFill>
+                            <a:srgbClr val="3D444C"/>
+                          </a:solidFill>
+                          <a:latin typeface="Arial"/>
+                          <a:ea typeface="Arial"/>
+                          <a:cs typeface="Arial"/>
+                        </a:rPr>
+                        <a:t>$1.20</a:t>
+                      </a:r>
+                    </a:p>
+                  </a:txBody>
+                  <a:tcPr anchor="ctr">
+                    <a:solidFill>
+                      <a:srgbClr val="FFFFFF"/>
+                    </a:solidFill>
+                  </a:tcPr>
+                </a:tc>
+                <a:tc>
+                  <a:txBody>
+                    <a:bodyPr wrap="square" lIns="88900" tIns="38100" rIns="88900" bIns="38100" anchor="ctr">
+                      <a:noAutofit/>
+                    </a:bodyPr>
+                    <a:lstStyle/>
+                    <a:p>
+                      <a:pPr marL="0" indent="0">
+                        <a:buNone/>
+                      </a:pPr>
+                      <a:r>
+                        <a:rPr lang="en-US" sz="1300" dirty="0">
+                          <a:solidFill>
+                            <a:srgbClr val="3D444C"/>
+                          </a:solidFill>
+                          <a:latin typeface="Arial"/>
+                          <a:ea typeface="Arial"/>
+                          <a:cs typeface="Arial"/>
+                        </a:rPr>
+                        <a:t>$0.75</a:t>
+                      </a:r>
+                    </a:p>
+                  </a:txBody>
+                  <a:tcPr anchor="ctr">
+                    <a:solidFill>
+                      <a:srgbClr val="FFFFFF"/>
+                    </a:solidFill>
+                  </a:tcPr>
+                </a:tc>
+              </a:tr>
+              <a:tr h="774700">
+                <a:tc>
+                  <a:txBody>
+                    <a:bodyPr wrap="square" lIns="88900" tIns="38100" rIns="88900" bIns="38100" anchor="ctr">
+                      <a:noAutofit/>
+                    </a:bodyPr>
+                    <a:lstStyle/>
+                    <a:p>
+                      <a:pPr marL="0" indent="0">
+                        <a:buNone/>
+                      </a:pPr>
+                      <a:r>
+                        <a:rPr lang="en-US" sz="1300" dirty="0">
+                          <a:solidFill>
+                            <a:srgbClr val="3D444C"/>
+                          </a:solidFill>
+                          <a:latin typeface="Arial"/>
+                          <a:ea typeface="Arial"/>
+                          <a:cs typeface="Arial"/>
+                        </a:rPr>
+                        <a:t>Adoption</a:t>
+                      </a:r>
+                    </a:p>
+                  </a:txBody>
+                  <a:tcPr anchor="ctr">
+                    <a:solidFill>
+                      <a:srgbClr val="FFFFFF"/>
+                    </a:solidFill>
+                  </a:tcPr>
+                </a:tc>
+                <a:tc>
+                  <a:txBody>
+                    <a:bodyPr wrap="square" lIns="88900" tIns="38100" rIns="88900" bIns="38100" anchor="ctr">
+                      <a:noAutofit/>
+                    </a:bodyPr>
+                    <a:lstStyle/>
+                    <a:p>
+                      <a:pPr marL="0" indent="0">
+                        <a:buNone/>
+                      </a:pPr>
+                      <a:r>
+                        <a:rPr lang="en-US" sz="1300" dirty="0">
+                          <a:solidFill>
+                            <a:srgbClr val="3D444C"/>
+                          </a:solidFill>
+                          <a:latin typeface="Arial"/>
+                          <a:ea typeface="Arial"/>
+                          <a:cs typeface="Arial"/>
+                        </a:rPr>
+                        <a:t>18%</a:t>
+                      </a:r>
+                    </a:p>
+                  </a:txBody>
+                  <a:tcPr anchor="ctr">
+                    <a:solidFill>
+                      <a:srgbClr val="FFFFFF"/>
+                    </a:solidFill>
+                  </a:tcPr>
+                </a:tc>
+                <a:tc>
+                  <a:txBody>
+                    <a:bodyPr wrap="square" lIns="88900" tIns="38100" rIns="88900" bIns="38100" anchor="ctr">
+                      <a:noAutofit/>
+                    </a:bodyPr>
+                    <a:lstStyle/>
+                    <a:p>
+                      <a:pPr marL="0" indent="0">
+                        <a:buNone/>
+                      </a:pPr>
+                      <a:r>
+                        <a:rPr lang="en-US" sz="1300" dirty="0">
+                          <a:solidFill>
+                            <a:srgbClr val="3D444C"/>
+                          </a:solidFill>
+                          <a:latin typeface="Arial"/>
+                          <a:ea typeface="Arial"/>
+                          <a:cs typeface="Arial"/>
+                        </a:rPr>
+                        <a:t>45%</a:t>
+                      </a:r>
+                    </a:p>
+                  </a:txBody>
+                  <a:tcPr anchor="ctr">
+                    <a:solidFill>
+                      <a:srgbClr val="FFFFFF"/>
+                    </a:solidFill>
+                  </a:tcPr>
+                </a:tc>
+              </a:tr>
+            </a:tbl>
+          </a:graphicData>
+        </a:graphic>
+      </p:graphicFrame>
+    </p:spTree>
+  </p:cSld>
+  <p:clrMapOvr>
+    <a:masterClrMapping/>
+  </p:clrMapOvr>
+</p:sld>
+</file>
+
 <file path=ppt/slides/slide2.xml><?xml version="1.0" encoding="utf-8"?>
 <p:sld xmlns:a="http://schemas.openxmlformats.org/drawingml/2006/main" xmlns:r="http://schemas.openxmlformats.org/officeDocument/2006/relationships" xmlns:p="http://schemas.openxmlformats.org/presentationml/2006/main">
   <p:cSld>

</xml_diff>